<commit_message>
another day another mistake
moderately-proportioned bruh moment
</commit_message>
<xml_diff>
--- a/figures/fig5/fig5.pptx
+++ b/figures/fig5/fig5.pptx
@@ -258,7 +258,7 @@
       </p15:sldGuideLst>
     </p:ext>
     <p:ext uri="http://customooxmlschemas.google.com/">
-      <go:slidesCustomData xmlns="" xmlns:mc="http://schemas.openxmlformats.org/markup-compatibility/2006" xmlns:mv="urn:schemas-microsoft-com:mac:vml" xmlns:c="http://schemas.openxmlformats.org/drawingml/2006/chart" xmlns:dgm="http://schemas.openxmlformats.org/drawingml/2006/diagram" xmlns:o="urn:schemas-microsoft-com:office:office" xmlns:v="urn:schemas-microsoft-com:vml" xmlns:pvml="urn:schemas-microsoft-com:office:powerpoint" xmlns:com="http://schemas.openxmlformats.org/drawingml/2006/compatibility" xmlns:p14="http://schemas.microsoft.com/office/powerpoint/2010/main" xmlns:p15="http://schemas.microsoft.com/office/powerpoint/2012/main" xmlns:ahyp="http://schemas.microsoft.com/office/drawing/2018/hyperlinkcolor" xmlns:go="http://customooxmlschemas.google.com/" r:id="rId10" roundtripDataSignature="AMtx7mhiytGPk8UOxiAGs9KaAxakDbg4SQ=="/>
+      <go:slidesCustomData xmlns:go="http://customooxmlschemas.google.com/" xmlns:ahyp="http://schemas.microsoft.com/office/drawing/2018/hyperlinkcolor" xmlns:p15="http://schemas.microsoft.com/office/powerpoint/2012/main" xmlns:p14="http://schemas.microsoft.com/office/powerpoint/2010/main" xmlns:com="http://schemas.openxmlformats.org/drawingml/2006/compatibility" xmlns:pvml="urn:schemas-microsoft-com:office:powerpoint" xmlns:v="urn:schemas-microsoft-com:vml" xmlns:o="urn:schemas-microsoft-com:office:office" xmlns:dgm="http://schemas.openxmlformats.org/drawingml/2006/diagram" xmlns:c="http://schemas.openxmlformats.org/drawingml/2006/chart" xmlns:mv="urn:schemas-microsoft-com:mac:vml" xmlns:mc="http://schemas.openxmlformats.org/markup-compatibility/2006" xmlns="" r:id="rId10" roundtripDataSignature="AMtx7mhiytGPk8UOxiAGs9KaAxakDbg4SQ=="/>
     </p:ext>
   </p:extLst>
 </p:presentation>
@@ -11946,10 +11946,10 @@
       </p:graphicFrame>
       <p:pic>
         <p:nvPicPr>
-          <p:cNvPr id="4" name="Graphic 3">
+          <p:cNvPr id="3" name="Graphic 2">
             <a:extLst>
               <a:ext uri="{FF2B5EF4-FFF2-40B4-BE49-F238E27FC236}">
-                <a16:creationId xmlns:a16="http://schemas.microsoft.com/office/drawing/2014/main" id="{8F51A865-9AF0-DCF9-2DB0-D95FF7F7F5E3}"/>
+                <a16:creationId xmlns:a16="http://schemas.microsoft.com/office/drawing/2014/main" id="{3181FD7B-49B9-1912-A3B2-E9AA8D38179E}"/>
               </a:ext>
             </a:extLst>
           </p:cNvPr>
@@ -11966,15 +11966,15 @@
               </a:ext>
             </a:extLst>
           </a:blip>
-          <a:srcRect l="2456" r="2381" b="3384"/>
+          <a:srcRect l="1875" r="2361" b="3020"/>
           <a:stretch>
             <a:fillRect/>
           </a:stretch>
         </p:blipFill>
         <p:spPr>
           <a:xfrm>
-            <a:off x="898525" y="6511332"/>
-            <a:ext cx="34806618" cy="19222497"/>
+            <a:off x="685800" y="6511332"/>
+            <a:ext cx="35026600" cy="19295068"/>
           </a:xfrm>
           <a:prstGeom prst="rect">
             <a:avLst/>
@@ -12149,510 +12149,6 @@
           </a:prstGeom>
         </p:spPr>
       </p:pic>
-      <p:sp>
-        <p:nvSpPr>
-          <p:cNvPr id="31" name="TextBox 30">
-            <a:extLst>
-              <a:ext uri="{FF2B5EF4-FFF2-40B4-BE49-F238E27FC236}">
-                <a16:creationId xmlns:a16="http://schemas.microsoft.com/office/drawing/2014/main" id="{2410C392-4511-5330-48DC-1AA35F808C54}"/>
-              </a:ext>
-            </a:extLst>
-          </p:cNvPr>
-          <p:cNvSpPr txBox="1"/>
-          <p:nvPr/>
-        </p:nvSpPr>
-        <p:spPr>
-          <a:xfrm>
-            <a:off x="13130410" y="16761301"/>
-            <a:ext cx="1684020" cy="230832"/>
-          </a:xfrm>
-          <a:prstGeom prst="rect">
-            <a:avLst/>
-          </a:prstGeom>
-          <a:noFill/>
-        </p:spPr>
-        <p:txBody>
-          <a:bodyPr wrap="square" rtlCol="0">
-            <a:spAutoFit/>
-          </a:bodyPr>
-          <a:lstStyle/>
-          <a:p>
-            <a:pPr algn="r"/>
-            <a:r>
-              <a:rPr lang="en-US" sz="900" dirty="0"/>
-              <a:t>DNA age</a:t>
-            </a:r>
-          </a:p>
-        </p:txBody>
-      </p:sp>
-      <p:sp>
-        <p:nvSpPr>
-          <p:cNvPr id="32" name="TextBox 31">
-            <a:extLst>
-              <a:ext uri="{FF2B5EF4-FFF2-40B4-BE49-F238E27FC236}">
-                <a16:creationId xmlns:a16="http://schemas.microsoft.com/office/drawing/2014/main" id="{2F6171B2-4D8C-D163-8A37-A4B27E57624E}"/>
-              </a:ext>
-            </a:extLst>
-          </p:cNvPr>
-          <p:cNvSpPr txBox="1"/>
-          <p:nvPr/>
-        </p:nvSpPr>
-        <p:spPr>
-          <a:xfrm>
-            <a:off x="13130410" y="16899413"/>
-            <a:ext cx="1684020" cy="230832"/>
-          </a:xfrm>
-          <a:prstGeom prst="rect">
-            <a:avLst/>
-          </a:prstGeom>
-          <a:noFill/>
-        </p:spPr>
-        <p:txBody>
-          <a:bodyPr wrap="square" rtlCol="0">
-            <a:spAutoFit/>
-          </a:bodyPr>
-          <a:lstStyle/>
-          <a:p>
-            <a:pPr algn="r"/>
-            <a:r>
-              <a:rPr lang="en-US" sz="900" dirty="0"/>
-              <a:t>DNA age x prop.</a:t>
-            </a:r>
-          </a:p>
-        </p:txBody>
-      </p:sp>
-      <p:sp>
-        <p:nvSpPr>
-          <p:cNvPr id="36" name="TextBox 35">
-            <a:extLst>
-              <a:ext uri="{FF2B5EF4-FFF2-40B4-BE49-F238E27FC236}">
-                <a16:creationId xmlns:a16="http://schemas.microsoft.com/office/drawing/2014/main" id="{E8AA23AD-EAC5-6D61-AE97-77E3AF46CEEB}"/>
-              </a:ext>
-            </a:extLst>
-          </p:cNvPr>
-          <p:cNvSpPr txBox="1"/>
-          <p:nvPr/>
-        </p:nvSpPr>
-        <p:spPr>
-          <a:xfrm>
-            <a:off x="13130410" y="17037525"/>
-            <a:ext cx="1684020" cy="230832"/>
-          </a:xfrm>
-          <a:prstGeom prst="rect">
-            <a:avLst/>
-          </a:prstGeom>
-          <a:noFill/>
-        </p:spPr>
-        <p:txBody>
-          <a:bodyPr wrap="square" rtlCol="0">
-            <a:spAutoFit/>
-          </a:bodyPr>
-          <a:lstStyle/>
-          <a:p>
-            <a:pPr algn="r"/>
-            <a:r>
-              <a:rPr lang="en-US" sz="900" dirty="0"/>
-              <a:t>LINE age</a:t>
-            </a:r>
-          </a:p>
-        </p:txBody>
-      </p:sp>
-      <p:sp>
-        <p:nvSpPr>
-          <p:cNvPr id="37" name="TextBox 36">
-            <a:extLst>
-              <a:ext uri="{FF2B5EF4-FFF2-40B4-BE49-F238E27FC236}">
-                <a16:creationId xmlns:a16="http://schemas.microsoft.com/office/drawing/2014/main" id="{6015D9E4-B2C6-90A1-D193-3E8F30084E98}"/>
-              </a:ext>
-            </a:extLst>
-          </p:cNvPr>
-          <p:cNvSpPr txBox="1"/>
-          <p:nvPr/>
-        </p:nvSpPr>
-        <p:spPr>
-          <a:xfrm>
-            <a:off x="13130410" y="17175637"/>
-            <a:ext cx="1684020" cy="230832"/>
-          </a:xfrm>
-          <a:prstGeom prst="rect">
-            <a:avLst/>
-          </a:prstGeom>
-          <a:noFill/>
-        </p:spPr>
-        <p:txBody>
-          <a:bodyPr wrap="square" rtlCol="0">
-            <a:spAutoFit/>
-          </a:bodyPr>
-          <a:lstStyle/>
-          <a:p>
-            <a:pPr algn="r"/>
-            <a:r>
-              <a:rPr lang="en-US" sz="900" dirty="0"/>
-              <a:t>LTR age x prop.</a:t>
-            </a:r>
-          </a:p>
-        </p:txBody>
-      </p:sp>
-      <p:sp>
-        <p:nvSpPr>
-          <p:cNvPr id="38" name="TextBox 37">
-            <a:extLst>
-              <a:ext uri="{FF2B5EF4-FFF2-40B4-BE49-F238E27FC236}">
-                <a16:creationId xmlns:a16="http://schemas.microsoft.com/office/drawing/2014/main" id="{6D75525C-1F6A-1BDE-8836-B8462CB9EEFB}"/>
-              </a:ext>
-            </a:extLst>
-          </p:cNvPr>
-          <p:cNvSpPr txBox="1"/>
-          <p:nvPr/>
-        </p:nvSpPr>
-        <p:spPr>
-          <a:xfrm>
-            <a:off x="13130410" y="17313749"/>
-            <a:ext cx="1684020" cy="230832"/>
-          </a:xfrm>
-          <a:prstGeom prst="rect">
-            <a:avLst/>
-          </a:prstGeom>
-          <a:noFill/>
-        </p:spPr>
-        <p:txBody>
-          <a:bodyPr wrap="square" rtlCol="0">
-            <a:spAutoFit/>
-          </a:bodyPr>
-          <a:lstStyle/>
-          <a:p>
-            <a:pPr algn="r"/>
-            <a:r>
-              <a:rPr lang="en-US" sz="900" dirty="0"/>
-              <a:t>Others age</a:t>
-            </a:r>
-          </a:p>
-        </p:txBody>
-      </p:sp>
-      <p:sp>
-        <p:nvSpPr>
-          <p:cNvPr id="56" name="TextBox 55">
-            <a:extLst>
-              <a:ext uri="{FF2B5EF4-FFF2-40B4-BE49-F238E27FC236}">
-                <a16:creationId xmlns:a16="http://schemas.microsoft.com/office/drawing/2014/main" id="{B998515C-07B0-1DEC-8115-3443BD05BE68}"/>
-              </a:ext>
-            </a:extLst>
-          </p:cNvPr>
-          <p:cNvSpPr txBox="1"/>
-          <p:nvPr/>
-        </p:nvSpPr>
-        <p:spPr>
-          <a:xfrm>
-            <a:off x="13130410" y="17451861"/>
-            <a:ext cx="1684020" cy="230832"/>
-          </a:xfrm>
-          <a:prstGeom prst="rect">
-            <a:avLst/>
-          </a:prstGeom>
-          <a:noFill/>
-        </p:spPr>
-        <p:txBody>
-          <a:bodyPr wrap="square" rtlCol="0">
-            <a:spAutoFit/>
-          </a:bodyPr>
-          <a:lstStyle/>
-          <a:p>
-            <a:pPr algn="r"/>
-            <a:r>
-              <a:rPr lang="en-US" sz="900" dirty="0"/>
-              <a:t>Others age x prop.</a:t>
-            </a:r>
-          </a:p>
-        </p:txBody>
-      </p:sp>
-      <p:sp>
-        <p:nvSpPr>
-          <p:cNvPr id="58" name="TextBox 57">
-            <a:extLst>
-              <a:ext uri="{FF2B5EF4-FFF2-40B4-BE49-F238E27FC236}">
-                <a16:creationId xmlns:a16="http://schemas.microsoft.com/office/drawing/2014/main" id="{CA0E7F28-443B-A2AC-176D-7DBD7F83B072}"/>
-              </a:ext>
-            </a:extLst>
-          </p:cNvPr>
-          <p:cNvSpPr txBox="1"/>
-          <p:nvPr/>
-        </p:nvSpPr>
-        <p:spPr>
-          <a:xfrm>
-            <a:off x="13131877" y="17589973"/>
-            <a:ext cx="1684020" cy="230832"/>
-          </a:xfrm>
-          <a:prstGeom prst="rect">
-            <a:avLst/>
-          </a:prstGeom>
-          <a:noFill/>
-        </p:spPr>
-        <p:txBody>
-          <a:bodyPr wrap="square" rtlCol="0">
-            <a:spAutoFit/>
-          </a:bodyPr>
-          <a:lstStyle/>
-          <a:p>
-            <a:pPr algn="r"/>
-            <a:r>
-              <a:rPr lang="en-US" sz="900" dirty="0"/>
-              <a:t>SINE age</a:t>
-            </a:r>
-          </a:p>
-        </p:txBody>
-      </p:sp>
-      <p:sp>
-        <p:nvSpPr>
-          <p:cNvPr id="59" name="TextBox 58">
-            <a:extLst>
-              <a:ext uri="{FF2B5EF4-FFF2-40B4-BE49-F238E27FC236}">
-                <a16:creationId xmlns:a16="http://schemas.microsoft.com/office/drawing/2014/main" id="{E563B509-27EF-29EB-AB3D-4CEBF4EAA433}"/>
-              </a:ext>
-            </a:extLst>
-          </p:cNvPr>
-          <p:cNvSpPr txBox="1"/>
-          <p:nvPr/>
-        </p:nvSpPr>
-        <p:spPr>
-          <a:xfrm>
-            <a:off x="13130410" y="17728085"/>
-            <a:ext cx="1684020" cy="230832"/>
-          </a:xfrm>
-          <a:prstGeom prst="rect">
-            <a:avLst/>
-          </a:prstGeom>
-          <a:noFill/>
-        </p:spPr>
-        <p:txBody>
-          <a:bodyPr wrap="square" rtlCol="0">
-            <a:spAutoFit/>
-          </a:bodyPr>
-          <a:lstStyle/>
-          <a:p>
-            <a:pPr algn="r"/>
-            <a:r>
-              <a:rPr lang="en-US" sz="900" dirty="0"/>
-              <a:t>Unknown age</a:t>
-            </a:r>
-          </a:p>
-        </p:txBody>
-      </p:sp>
-      <p:sp>
-        <p:nvSpPr>
-          <p:cNvPr id="60" name="TextBox 59">
-            <a:extLst>
-              <a:ext uri="{FF2B5EF4-FFF2-40B4-BE49-F238E27FC236}">
-                <a16:creationId xmlns:a16="http://schemas.microsoft.com/office/drawing/2014/main" id="{178D3284-8479-B1EE-5C7D-DB0F0745DB66}"/>
-              </a:ext>
-            </a:extLst>
-          </p:cNvPr>
-          <p:cNvSpPr txBox="1"/>
-          <p:nvPr/>
-        </p:nvSpPr>
-        <p:spPr>
-          <a:xfrm>
-            <a:off x="13130410" y="17862249"/>
-            <a:ext cx="1684020" cy="230832"/>
-          </a:xfrm>
-          <a:prstGeom prst="rect">
-            <a:avLst/>
-          </a:prstGeom>
-          <a:noFill/>
-        </p:spPr>
-        <p:txBody>
-          <a:bodyPr wrap="square" rtlCol="0">
-            <a:spAutoFit/>
-          </a:bodyPr>
-          <a:lstStyle/>
-          <a:p>
-            <a:pPr algn="r"/>
-            <a:r>
-              <a:rPr lang="en-US" sz="900" dirty="0"/>
-              <a:t>Unknown age x prop.</a:t>
-            </a:r>
-          </a:p>
-        </p:txBody>
-      </p:sp>
-      <p:sp>
-        <p:nvSpPr>
-          <p:cNvPr id="61" name="TextBox 60">
-            <a:extLst>
-              <a:ext uri="{FF2B5EF4-FFF2-40B4-BE49-F238E27FC236}">
-                <a16:creationId xmlns:a16="http://schemas.microsoft.com/office/drawing/2014/main" id="{577AFB92-0CEE-50C0-1672-4EE0E521D42D}"/>
-              </a:ext>
-            </a:extLst>
-          </p:cNvPr>
-          <p:cNvSpPr txBox="1"/>
-          <p:nvPr/>
-        </p:nvSpPr>
-        <p:spPr>
-          <a:xfrm>
-            <a:off x="13130410" y="18003556"/>
-            <a:ext cx="1684020" cy="230832"/>
-          </a:xfrm>
-          <a:prstGeom prst="rect">
-            <a:avLst/>
-          </a:prstGeom>
-          <a:noFill/>
-        </p:spPr>
-        <p:txBody>
-          <a:bodyPr wrap="square" rtlCol="0">
-            <a:spAutoFit/>
-          </a:bodyPr>
-          <a:lstStyle/>
-          <a:p>
-            <a:pPr algn="r"/>
-            <a:r>
-              <a:rPr lang="en-US" sz="900" dirty="0"/>
-              <a:t>LINE proportion</a:t>
-            </a:r>
-          </a:p>
-        </p:txBody>
-      </p:sp>
-      <p:sp>
-        <p:nvSpPr>
-          <p:cNvPr id="62" name="TextBox 61">
-            <a:extLst>
-              <a:ext uri="{FF2B5EF4-FFF2-40B4-BE49-F238E27FC236}">
-                <a16:creationId xmlns:a16="http://schemas.microsoft.com/office/drawing/2014/main" id="{85611B5F-9927-2CE2-6145-5DB590DF5C7D}"/>
-              </a:ext>
-            </a:extLst>
-          </p:cNvPr>
-          <p:cNvSpPr txBox="1"/>
-          <p:nvPr/>
-        </p:nvSpPr>
-        <p:spPr>
-          <a:xfrm>
-            <a:off x="13131878" y="18142421"/>
-            <a:ext cx="1684020" cy="230832"/>
-          </a:xfrm>
-          <a:prstGeom prst="rect">
-            <a:avLst/>
-          </a:prstGeom>
-          <a:noFill/>
-        </p:spPr>
-        <p:txBody>
-          <a:bodyPr wrap="square" rtlCol="0">
-            <a:spAutoFit/>
-          </a:bodyPr>
-          <a:lstStyle/>
-          <a:p>
-            <a:pPr algn="r"/>
-            <a:r>
-              <a:rPr lang="en-US" sz="900" dirty="0"/>
-              <a:t>LTR proportion</a:t>
-            </a:r>
-          </a:p>
-        </p:txBody>
-      </p:sp>
-      <p:sp>
-        <p:nvSpPr>
-          <p:cNvPr id="63" name="TextBox 62">
-            <a:extLst>
-              <a:ext uri="{FF2B5EF4-FFF2-40B4-BE49-F238E27FC236}">
-                <a16:creationId xmlns:a16="http://schemas.microsoft.com/office/drawing/2014/main" id="{17073772-114C-4DCE-D32C-542270626B80}"/>
-              </a:ext>
-            </a:extLst>
-          </p:cNvPr>
-          <p:cNvSpPr txBox="1"/>
-          <p:nvPr/>
-        </p:nvSpPr>
-        <p:spPr>
-          <a:xfrm>
-            <a:off x="13130410" y="18278966"/>
-            <a:ext cx="1684020" cy="230832"/>
-          </a:xfrm>
-          <a:prstGeom prst="rect">
-            <a:avLst/>
-          </a:prstGeom>
-          <a:noFill/>
-        </p:spPr>
-        <p:txBody>
-          <a:bodyPr wrap="square" rtlCol="0">
-            <a:spAutoFit/>
-          </a:bodyPr>
-          <a:lstStyle/>
-          <a:p>
-            <a:pPr algn="r"/>
-            <a:r>
-              <a:rPr lang="en-US" sz="900" dirty="0"/>
-              <a:t>Others proportion</a:t>
-            </a:r>
-          </a:p>
-        </p:txBody>
-      </p:sp>
-      <p:sp>
-        <p:nvSpPr>
-          <p:cNvPr id="64" name="TextBox 63">
-            <a:extLst>
-              <a:ext uri="{FF2B5EF4-FFF2-40B4-BE49-F238E27FC236}">
-                <a16:creationId xmlns:a16="http://schemas.microsoft.com/office/drawing/2014/main" id="{05116E87-0CF0-64E3-69EF-9FA6D57711B3}"/>
-              </a:ext>
-            </a:extLst>
-          </p:cNvPr>
-          <p:cNvSpPr txBox="1"/>
-          <p:nvPr/>
-        </p:nvSpPr>
-        <p:spPr>
-          <a:xfrm>
-            <a:off x="13130410" y="18417078"/>
-            <a:ext cx="1684020" cy="230832"/>
-          </a:xfrm>
-          <a:prstGeom prst="rect">
-            <a:avLst/>
-          </a:prstGeom>
-          <a:noFill/>
-        </p:spPr>
-        <p:txBody>
-          <a:bodyPr wrap="square" rtlCol="0">
-            <a:spAutoFit/>
-          </a:bodyPr>
-          <a:lstStyle/>
-          <a:p>
-            <a:pPr algn="r"/>
-            <a:r>
-              <a:rPr lang="en-US" sz="900" dirty="0"/>
-              <a:t>SINE proportion</a:t>
-            </a:r>
-          </a:p>
-        </p:txBody>
-      </p:sp>
-      <p:sp>
-        <p:nvSpPr>
-          <p:cNvPr id="65" name="TextBox 64">
-            <a:extLst>
-              <a:ext uri="{FF2B5EF4-FFF2-40B4-BE49-F238E27FC236}">
-                <a16:creationId xmlns:a16="http://schemas.microsoft.com/office/drawing/2014/main" id="{1A21A716-E86B-D606-2E34-B1D75AE912AD}"/>
-              </a:ext>
-            </a:extLst>
-          </p:cNvPr>
-          <p:cNvSpPr txBox="1"/>
-          <p:nvPr/>
-        </p:nvSpPr>
-        <p:spPr>
-          <a:xfrm>
-            <a:off x="13130410" y="18553623"/>
-            <a:ext cx="1684020" cy="230832"/>
-          </a:xfrm>
-          <a:prstGeom prst="rect">
-            <a:avLst/>
-          </a:prstGeom>
-          <a:noFill/>
-        </p:spPr>
-        <p:txBody>
-          <a:bodyPr wrap="square" rtlCol="0">
-            <a:spAutoFit/>
-          </a:bodyPr>
-          <a:lstStyle/>
-          <a:p>
-            <a:pPr algn="r"/>
-            <a:r>
-              <a:rPr lang="en-US" sz="900" dirty="0"/>
-              <a:t>Unknown proportion</a:t>
-            </a:r>
-          </a:p>
-        </p:txBody>
-      </p:sp>
       <p:sp>
         <p:nvSpPr>
           <p:cNvPr id="66" name="TextBox 65">
@@ -14078,6 +13574,222 @@
           </a:p>
         </p:txBody>
       </p:sp>
+      <p:sp>
+        <p:nvSpPr>
+          <p:cNvPr id="11" name="TextBox 10">
+            <a:extLst>
+              <a:ext uri="{FF2B5EF4-FFF2-40B4-BE49-F238E27FC236}">
+                <a16:creationId xmlns:a16="http://schemas.microsoft.com/office/drawing/2014/main" id="{A2508C01-A1EB-EF40-5D95-D31A2E6C1253}"/>
+              </a:ext>
+            </a:extLst>
+          </p:cNvPr>
+          <p:cNvSpPr txBox="1"/>
+          <p:nvPr/>
+        </p:nvSpPr>
+        <p:spPr>
+          <a:xfrm>
+            <a:off x="13130407" y="16909659"/>
+            <a:ext cx="1684020" cy="292388"/>
+          </a:xfrm>
+          <a:prstGeom prst="rect">
+            <a:avLst/>
+          </a:prstGeom>
+          <a:noFill/>
+        </p:spPr>
+        <p:txBody>
+          <a:bodyPr wrap="square" rtlCol="0">
+            <a:spAutoFit/>
+          </a:bodyPr>
+          <a:lstStyle/>
+          <a:p>
+            <a:pPr algn="r"/>
+            <a:r>
+              <a:rPr lang="en-US" sz="1300" dirty="0"/>
+              <a:t>LTR age</a:t>
+            </a:r>
+          </a:p>
+        </p:txBody>
+      </p:sp>
+      <p:sp>
+        <p:nvSpPr>
+          <p:cNvPr id="12" name="TextBox 11">
+            <a:extLst>
+              <a:ext uri="{FF2B5EF4-FFF2-40B4-BE49-F238E27FC236}">
+                <a16:creationId xmlns:a16="http://schemas.microsoft.com/office/drawing/2014/main" id="{EA2A1E8E-AB97-6772-56B4-ADA17F0620FE}"/>
+              </a:ext>
+            </a:extLst>
+          </p:cNvPr>
+          <p:cNvSpPr txBox="1"/>
+          <p:nvPr/>
+        </p:nvSpPr>
+        <p:spPr>
+          <a:xfrm>
+            <a:off x="13130400" y="17203350"/>
+            <a:ext cx="1684020" cy="292388"/>
+          </a:xfrm>
+          <a:prstGeom prst="rect">
+            <a:avLst/>
+          </a:prstGeom>
+          <a:noFill/>
+        </p:spPr>
+        <p:txBody>
+          <a:bodyPr wrap="square" rtlCol="0">
+            <a:spAutoFit/>
+          </a:bodyPr>
+          <a:lstStyle/>
+          <a:p>
+            <a:pPr algn="r"/>
+            <a:r>
+              <a:rPr lang="en-US" sz="1300" dirty="0"/>
+              <a:t>SINE age</a:t>
+            </a:r>
+          </a:p>
+        </p:txBody>
+      </p:sp>
+      <p:sp>
+        <p:nvSpPr>
+          <p:cNvPr id="13" name="TextBox 12">
+            <a:extLst>
+              <a:ext uri="{FF2B5EF4-FFF2-40B4-BE49-F238E27FC236}">
+                <a16:creationId xmlns:a16="http://schemas.microsoft.com/office/drawing/2014/main" id="{554928CD-06A1-8F7D-A6DA-B87A71D6AE66}"/>
+              </a:ext>
+            </a:extLst>
+          </p:cNvPr>
+          <p:cNvSpPr txBox="1"/>
+          <p:nvPr/>
+        </p:nvSpPr>
+        <p:spPr>
+          <a:xfrm>
+            <a:off x="13130391" y="17495450"/>
+            <a:ext cx="1684020" cy="292388"/>
+          </a:xfrm>
+          <a:prstGeom prst="rect">
+            <a:avLst/>
+          </a:prstGeom>
+          <a:noFill/>
+        </p:spPr>
+        <p:txBody>
+          <a:bodyPr wrap="square" rtlCol="0">
+            <a:spAutoFit/>
+          </a:bodyPr>
+          <a:lstStyle/>
+          <a:p>
+            <a:pPr algn="r"/>
+            <a:r>
+              <a:rPr lang="en-US" sz="1300" dirty="0"/>
+              <a:t>Unknown age</a:t>
+            </a:r>
+          </a:p>
+        </p:txBody>
+      </p:sp>
+      <p:sp>
+        <p:nvSpPr>
+          <p:cNvPr id="14" name="TextBox 13">
+            <a:extLst>
+              <a:ext uri="{FF2B5EF4-FFF2-40B4-BE49-F238E27FC236}">
+                <a16:creationId xmlns:a16="http://schemas.microsoft.com/office/drawing/2014/main" id="{E94EA363-67A1-881C-8196-E8318DC3ED99}"/>
+              </a:ext>
+            </a:extLst>
+          </p:cNvPr>
+          <p:cNvSpPr txBox="1"/>
+          <p:nvPr/>
+        </p:nvSpPr>
+        <p:spPr>
+          <a:xfrm>
+            <a:off x="13130388" y="17789136"/>
+            <a:ext cx="1684020" cy="292388"/>
+          </a:xfrm>
+          <a:prstGeom prst="rect">
+            <a:avLst/>
+          </a:prstGeom>
+          <a:noFill/>
+        </p:spPr>
+        <p:txBody>
+          <a:bodyPr wrap="square" rtlCol="0">
+            <a:spAutoFit/>
+          </a:bodyPr>
+          <a:lstStyle/>
+          <a:p>
+            <a:pPr algn="r"/>
+            <a:r>
+              <a:rPr lang="en-US" sz="1300" dirty="0"/>
+              <a:t>LTR proportion</a:t>
+            </a:r>
+          </a:p>
+        </p:txBody>
+      </p:sp>
+      <p:sp>
+        <p:nvSpPr>
+          <p:cNvPr id="15" name="TextBox 14">
+            <a:extLst>
+              <a:ext uri="{FF2B5EF4-FFF2-40B4-BE49-F238E27FC236}">
+                <a16:creationId xmlns:a16="http://schemas.microsoft.com/office/drawing/2014/main" id="{6C8F59F4-368F-732E-E11F-DB453E0F54B9}"/>
+              </a:ext>
+            </a:extLst>
+          </p:cNvPr>
+          <p:cNvSpPr txBox="1"/>
+          <p:nvPr/>
+        </p:nvSpPr>
+        <p:spPr>
+          <a:xfrm>
+            <a:off x="13130381" y="18082830"/>
+            <a:ext cx="1684020" cy="292388"/>
+          </a:xfrm>
+          <a:prstGeom prst="rect">
+            <a:avLst/>
+          </a:prstGeom>
+          <a:noFill/>
+        </p:spPr>
+        <p:txBody>
+          <a:bodyPr wrap="square" rtlCol="0">
+            <a:spAutoFit/>
+          </a:bodyPr>
+          <a:lstStyle/>
+          <a:p>
+            <a:pPr algn="r"/>
+            <a:r>
+              <a:rPr lang="en-US" sz="1300" dirty="0"/>
+              <a:t>Others proportion</a:t>
+            </a:r>
+          </a:p>
+        </p:txBody>
+      </p:sp>
+      <p:sp>
+        <p:nvSpPr>
+          <p:cNvPr id="16" name="TextBox 15">
+            <a:extLst>
+              <a:ext uri="{FF2B5EF4-FFF2-40B4-BE49-F238E27FC236}">
+                <a16:creationId xmlns:a16="http://schemas.microsoft.com/office/drawing/2014/main" id="{22485558-E7B8-7461-F722-2E4799B7D271}"/>
+              </a:ext>
+            </a:extLst>
+          </p:cNvPr>
+          <p:cNvSpPr txBox="1"/>
+          <p:nvPr/>
+        </p:nvSpPr>
+        <p:spPr>
+          <a:xfrm>
+            <a:off x="13130372" y="18373339"/>
+            <a:ext cx="1684020" cy="292388"/>
+          </a:xfrm>
+          <a:prstGeom prst="rect">
+            <a:avLst/>
+          </a:prstGeom>
+          <a:noFill/>
+        </p:spPr>
+        <p:txBody>
+          <a:bodyPr wrap="square" rtlCol="0">
+            <a:spAutoFit/>
+          </a:bodyPr>
+          <a:lstStyle/>
+          <a:p>
+            <a:pPr algn="r"/>
+            <a:r>
+              <a:rPr lang="en-US" sz="1300" dirty="0"/>
+              <a:t>Unknow proportion</a:t>
+            </a:r>
+          </a:p>
+        </p:txBody>
+      </p:sp>
     </p:spTree>
     <p:extLst>
       <p:ext uri="{BB962C8B-B14F-4D97-AF65-F5344CB8AC3E}">

</xml_diff>